<commit_message>
Replace Week 4 pre-lecture materials, add Week 5 L5.2 pre-lecture materials
Week 4 (L4.1-L4.3): updated PreLec PPTX/PDF from the latest raw source.
Week 5: L5.1 PreLec PPTX/PDF updated; L5.2 PreLec PPTX/PDF now added
and linked (the new source is 10MB vs. the previous 510MB, so it fits
under GitHub's file size limit).

Co-Authored-By: Claude Sonnet 5 <noreply@anthropic.com>
</commit_message>
<xml_diff>
--- a/html/COMP-_L4.1_PreLec.pptx
+++ b/html/COMP-_L4.1_PreLec.pptx
@@ -7,6 +7,9 @@
   <p:notesMasterIdLst>
     <p:notesMasterId r:id="rId16"/>
   </p:notesMasterIdLst>
+  <p:handoutMasterIdLst>
+    <p:handoutMasterId r:id="rId17"/>
+  </p:handoutMasterIdLst>
   <p:sldIdLst>
     <p:sldId id="256" r:id="rId2"/>
     <p:sldId id="257" r:id="rId3"/>
@@ -139,6 +142,195 @@
 </p:presentation>
 </file>
 
+<file path=ppt/handoutMasters/handoutMaster1.xml><?xml version="1.0" encoding="utf-8"?>
+<p:handoutMaster xmlns:a="http://schemas.openxmlformats.org/drawingml/2006/main" xmlns:r="http://schemas.openxmlformats.org/officeDocument/2006/relationships" xmlns:p="http://schemas.openxmlformats.org/presentationml/2006/main">
+  <p:cSld>
+    <p:bg>
+      <p:bgRef idx="1001">
+        <a:schemeClr val="bg1"/>
+      </p:bgRef>
+    </p:bg>
+    <p:spTree>
+      <p:nvGrpSpPr>
+        <p:cNvPr id="1" name=""/>
+        <p:cNvGrpSpPr/>
+        <p:nvPr/>
+      </p:nvGrpSpPr>
+      <p:grpSpPr>
+        <a:xfrm>
+          <a:off x="0" y="0"/>
+          <a:ext cx="0" cy="0"/>
+          <a:chOff x="0" y="0"/>
+          <a:chExt cx="0" cy="0"/>
+        </a:xfrm>
+      </p:grpSpPr>
+      <p:sp>
+        <p:nvSpPr>
+          <p:cNvPr id="2" name="Header Placeholder 1">
+            <a:extLst>
+              <a:ext uri="{FF2B5EF4-FFF2-40B4-BE49-F238E27FC236}">
+                <a16:creationId xmlns:a16="http://schemas.microsoft.com/office/drawing/2014/main" id="{F3B12377-2E7C-EFB2-60F9-F287D9F6F594}"/>
+              </a:ext>
+            </a:extLst>
+          </p:cNvPr>
+          <p:cNvSpPr>
+            <a:spLocks noGrp="1"/>
+          </p:cNvSpPr>
+          <p:nvPr>
+            <p:ph type="hdr" sz="quarter"/>
+          </p:nvPr>
+        </p:nvSpPr>
+        <p:spPr>
+          <a:xfrm>
+            <a:off x="0" y="0"/>
+            <a:ext cx="2971800" cy="458788"/>
+          </a:xfrm>
+          <a:prstGeom prst="rect">
+            <a:avLst/>
+          </a:prstGeom>
+        </p:spPr>
+        <p:txBody>
+          <a:bodyPr vert="horz" lIns="91440" tIns="45720" rIns="91440" bIns="45720" rtlCol="0"/>
+          <a:lstStyle>
+            <a:lvl1pPr algn="l">
+              <a:defRPr sz="1200"/>
+            </a:lvl1pPr>
+          </a:lstStyle>
+          <a:p>
+            <a:endParaRPr lang="en-001"/>
+          </a:p>
+        </p:txBody>
+      </p:sp>
+      <p:sp>
+        <p:nvSpPr>
+          <p:cNvPr id="3" name="Date Placeholder 2">
+            <a:extLst>
+              <a:ext uri="{FF2B5EF4-FFF2-40B4-BE49-F238E27FC236}">
+                <a16:creationId xmlns:a16="http://schemas.microsoft.com/office/drawing/2014/main" id="{7C4A4223-A53C-58BC-1F79-71F115076D58}"/>
+              </a:ext>
+            </a:extLst>
+          </p:cNvPr>
+          <p:cNvSpPr>
+            <a:spLocks noGrp="1"/>
+          </p:cNvSpPr>
+          <p:nvPr>
+            <p:ph type="dt" sz="quarter" idx="1"/>
+          </p:nvPr>
+        </p:nvSpPr>
+        <p:spPr>
+          <a:xfrm>
+            <a:off x="3884613" y="0"/>
+            <a:ext cx="2971800" cy="458788"/>
+          </a:xfrm>
+          <a:prstGeom prst="rect">
+            <a:avLst/>
+          </a:prstGeom>
+        </p:spPr>
+        <p:txBody>
+          <a:bodyPr vert="horz" lIns="91440" tIns="45720" rIns="91440" bIns="45720" rtlCol="0"/>
+          <a:lstStyle>
+            <a:lvl1pPr algn="r">
+              <a:defRPr sz="1200"/>
+            </a:lvl1pPr>
+          </a:lstStyle>
+          <a:p>
+            <a:fld id="{BEB01D81-1374-D94A-9FC1-643B3B8DB755}" type="datetimeFigureOut">
+              <a:rPr lang="en-001" smtClean="0"/>
+              <a:t>12/10/2026</a:t>
+            </a:fld>
+            <a:endParaRPr lang="en-001"/>
+          </a:p>
+        </p:txBody>
+      </p:sp>
+      <p:sp>
+        <p:nvSpPr>
+          <p:cNvPr id="4" name="Footer Placeholder 3">
+            <a:extLst>
+              <a:ext uri="{FF2B5EF4-FFF2-40B4-BE49-F238E27FC236}">
+                <a16:creationId xmlns:a16="http://schemas.microsoft.com/office/drawing/2014/main" id="{200FCACA-76CA-223B-D1F8-286275115682}"/>
+              </a:ext>
+            </a:extLst>
+          </p:cNvPr>
+          <p:cNvSpPr>
+            <a:spLocks noGrp="1"/>
+          </p:cNvSpPr>
+          <p:nvPr>
+            <p:ph type="ftr" sz="quarter" idx="2"/>
+          </p:nvPr>
+        </p:nvSpPr>
+        <p:spPr>
+          <a:xfrm>
+            <a:off x="0" y="8685213"/>
+            <a:ext cx="2971800" cy="458787"/>
+          </a:xfrm>
+          <a:prstGeom prst="rect">
+            <a:avLst/>
+          </a:prstGeom>
+        </p:spPr>
+        <p:txBody>
+          <a:bodyPr vert="horz" lIns="91440" tIns="45720" rIns="91440" bIns="45720" rtlCol="0" anchor="b"/>
+          <a:lstStyle>
+            <a:lvl1pPr algn="l">
+              <a:defRPr sz="1200"/>
+            </a:lvl1pPr>
+          </a:lstStyle>
+          <a:p>
+            <a:endParaRPr lang="en-001"/>
+          </a:p>
+        </p:txBody>
+      </p:sp>
+      <p:sp>
+        <p:nvSpPr>
+          <p:cNvPr id="5" name="Slide Number Placeholder 4">
+            <a:extLst>
+              <a:ext uri="{FF2B5EF4-FFF2-40B4-BE49-F238E27FC236}">
+                <a16:creationId xmlns:a16="http://schemas.microsoft.com/office/drawing/2014/main" id="{18EF81F7-3EC1-F1CC-F6A8-9749238597EF}"/>
+              </a:ext>
+            </a:extLst>
+          </p:cNvPr>
+          <p:cNvSpPr>
+            <a:spLocks noGrp="1"/>
+          </p:cNvSpPr>
+          <p:nvPr>
+            <p:ph type="sldNum" sz="quarter" idx="3"/>
+          </p:nvPr>
+        </p:nvSpPr>
+        <p:spPr>
+          <a:xfrm>
+            <a:off x="3884613" y="8685213"/>
+            <a:ext cx="2971800" cy="458787"/>
+          </a:xfrm>
+          <a:prstGeom prst="rect">
+            <a:avLst/>
+          </a:prstGeom>
+        </p:spPr>
+        <p:txBody>
+          <a:bodyPr vert="horz" lIns="91440" tIns="45720" rIns="91440" bIns="45720" rtlCol="0" anchor="b"/>
+          <a:lstStyle>
+            <a:lvl1pPr algn="r">
+              <a:defRPr sz="1200"/>
+            </a:lvl1pPr>
+          </a:lstStyle>
+          <a:p>
+            <a:fld id="{E6D23DA4-CC2F-624E-984F-5887AFCD239D}" type="slidenum">
+              <a:rPr lang="en-001" smtClean="0"/>
+              <a:t>‹#›</a:t>
+            </a:fld>
+            <a:endParaRPr lang="en-001"/>
+          </a:p>
+        </p:txBody>
+      </p:sp>
+    </p:spTree>
+    <p:extLst>
+      <p:ext uri="{BB962C8B-B14F-4D97-AF65-F5344CB8AC3E}">
+        <p14:creationId xmlns:p14="http://schemas.microsoft.com/office/powerpoint/2010/main" val="1190929907"/>
+      </p:ext>
+    </p:extLst>
+  </p:cSld>
+  <p:clrMap bg1="lt1" tx1="dk1" bg2="lt2" tx2="dk2" accent1="accent1" accent2="accent2" accent3="accent3" accent4="accent4" accent5="accent5" accent6="accent6" hlink="hlink" folHlink="folHlink"/>
+</p:handoutMaster>
+</file>
+
 <file path=ppt/notesMasters/notesMaster1.xml><?xml version="1.0" encoding="utf-8"?>
 <p:notesMaster xmlns:a="http://schemas.openxmlformats.org/drawingml/2006/main" xmlns:r="http://schemas.openxmlformats.org/officeDocument/2006/relationships" xmlns:p="http://schemas.openxmlformats.org/presentationml/2006/main">
   <p:cSld>
@@ -221,7 +413,7 @@
           <a:p>
             <a:fld id="{5B3C0760-A542-FE4F-8EBF-B1B1FB6407CD}" type="datetimeFigureOut">
               <a:rPr lang="en-001" smtClean="0"/>
-              <a:t>07/10/2026</a:t>
+              <a:t>12/10/2026</a:t>
             </a:fld>
             <a:endParaRPr lang="en-001"/>
           </a:p>
@@ -881,7 +1073,7 @@
           <a:p>
             <a:fld id="{5BCAD085-E8A6-8845-BD4E-CB4CCA059FC4}" type="datetimeFigureOut">
               <a:rPr lang="en-US" smtClean="0"/>
-              <a:t>10/7/26</a:t>
+              <a:t>10/12/26</a:t>
             </a:fld>
             <a:endParaRPr lang="en-US"/>
           </a:p>
@@ -1049,7 +1241,7 @@
           <a:p>
             <a:fld id="{5BCAD085-E8A6-8845-BD4E-CB4CCA059FC4}" type="datetimeFigureOut">
               <a:rPr lang="en-US" smtClean="0"/>
-              <a:t>10/7/26</a:t>
+              <a:t>10/12/26</a:t>
             </a:fld>
             <a:endParaRPr lang="en-US"/>
           </a:p>
@@ -1227,7 +1419,7 @@
           <a:p>
             <a:fld id="{5BCAD085-E8A6-8845-BD4E-CB4CCA059FC4}" type="datetimeFigureOut">
               <a:rPr lang="en-US" smtClean="0"/>
-              <a:t>10/7/26</a:t>
+              <a:t>10/12/26</a:t>
             </a:fld>
             <a:endParaRPr lang="en-US"/>
           </a:p>
@@ -1395,9 +1587,9 @@
           <a:p>
             <a:fld id="{5BCAD085-E8A6-8845-BD4E-CB4CCA059FC4}" type="datetimeFigureOut">
               <a:rPr lang="en-US" smtClean="0"/>
-              <a:t>10/7/26</a:t>
+              <a:t>10/12/26</a:t>
             </a:fld>
-            <a:endParaRPr lang="en-US"/>
+            <a:endParaRPr lang="en-US" dirty="0"/>
           </a:p>
         </p:txBody>
       </p:sp>
@@ -1440,6 +1632,38 @@
               <a:t>‹#›</a:t>
             </a:fld>
             <a:endParaRPr lang="en-US"/>
+          </a:p>
+        </p:txBody>
+      </p:sp>
+      <p:sp>
+        <p:nvSpPr>
+          <p:cNvPr id="7" name="TextBox 6">
+            <a:extLst>
+              <a:ext uri="{FF2B5EF4-FFF2-40B4-BE49-F238E27FC236}">
+                <a16:creationId xmlns:a16="http://schemas.microsoft.com/office/drawing/2014/main" id="{20EBB395-2FC9-B144-0D15-934B4F5105F9}"/>
+              </a:ext>
+            </a:extLst>
+          </p:cNvPr>
+          <p:cNvSpPr txBox="1"/>
+          <p:nvPr userDrawn="1"/>
+        </p:nvSpPr>
+        <p:spPr>
+          <a:xfrm>
+            <a:off x="1381539" y="6490252"/>
+            <a:ext cx="184731" cy="369332"/>
+          </a:xfrm>
+          <a:prstGeom prst="rect">
+            <a:avLst/>
+          </a:prstGeom>
+          <a:noFill/>
+        </p:spPr>
+        <p:txBody>
+          <a:bodyPr wrap="none" rtlCol="0">
+            <a:spAutoFit/>
+          </a:bodyPr>
+          <a:lstStyle/>
+          <a:p>
+            <a:endParaRPr lang="en-001" dirty="0"/>
           </a:p>
         </p:txBody>
       </p:sp>
@@ -1640,7 +1864,7 @@
           <a:p>
             <a:fld id="{5BCAD085-E8A6-8845-BD4E-CB4CCA059FC4}" type="datetimeFigureOut">
               <a:rPr lang="en-US" smtClean="0"/>
-              <a:t>10/7/26</a:t>
+              <a:t>10/12/26</a:t>
             </a:fld>
             <a:endParaRPr lang="en-US"/>
           </a:p>
@@ -1925,7 +2149,7 @@
           <a:p>
             <a:fld id="{5BCAD085-E8A6-8845-BD4E-CB4CCA059FC4}" type="datetimeFigureOut">
               <a:rPr lang="en-US" smtClean="0"/>
-              <a:t>10/7/26</a:t>
+              <a:t>10/12/26</a:t>
             </a:fld>
             <a:endParaRPr lang="en-US"/>
           </a:p>
@@ -2344,7 +2568,7 @@
           <a:p>
             <a:fld id="{5BCAD085-E8A6-8845-BD4E-CB4CCA059FC4}" type="datetimeFigureOut">
               <a:rPr lang="en-US" smtClean="0"/>
-              <a:t>10/7/26</a:t>
+              <a:t>10/12/26</a:t>
             </a:fld>
             <a:endParaRPr lang="en-US"/>
           </a:p>
@@ -2461,7 +2685,7 @@
           <a:p>
             <a:fld id="{5BCAD085-E8A6-8845-BD4E-CB4CCA059FC4}" type="datetimeFigureOut">
               <a:rPr lang="en-US" smtClean="0"/>
-              <a:t>10/7/26</a:t>
+              <a:t>10/12/26</a:t>
             </a:fld>
             <a:endParaRPr lang="en-US"/>
           </a:p>
@@ -2556,7 +2780,7 @@
           <a:p>
             <a:fld id="{5BCAD085-E8A6-8845-BD4E-CB4CCA059FC4}" type="datetimeFigureOut">
               <a:rPr lang="en-US" smtClean="0"/>
-              <a:t>10/7/26</a:t>
+              <a:t>10/12/26</a:t>
             </a:fld>
             <a:endParaRPr lang="en-US"/>
           </a:p>
@@ -2831,7 +3055,7 @@
           <a:p>
             <a:fld id="{5BCAD085-E8A6-8845-BD4E-CB4CCA059FC4}" type="datetimeFigureOut">
               <a:rPr lang="en-US" smtClean="0"/>
-              <a:t>10/7/26</a:t>
+              <a:t>10/12/26</a:t>
             </a:fld>
             <a:endParaRPr lang="en-US"/>
           </a:p>
@@ -3083,7 +3307,7 @@
           <a:p>
             <a:fld id="{5BCAD085-E8A6-8845-BD4E-CB4CCA059FC4}" type="datetimeFigureOut">
               <a:rPr lang="en-US" smtClean="0"/>
-              <a:t>10/7/26</a:t>
+              <a:t>10/12/26</a:t>
             </a:fld>
             <a:endParaRPr lang="en-US"/>
           </a:p>
@@ -3294,7 +3518,7 @@
           <a:p>
             <a:fld id="{5BCAD085-E8A6-8845-BD4E-CB4CCA059FC4}" type="datetimeFigureOut">
               <a:rPr lang="en-US" smtClean="0"/>
-              <a:t>10/7/26</a:t>
+              <a:t>10/12/26</a:t>
             </a:fld>
             <a:endParaRPr lang="en-US"/>
           </a:p>
@@ -3375,6 +3599,146 @@
               <a:t>‹#›</a:t>
             </a:fld>
             <a:endParaRPr lang="en-US"/>
+          </a:p>
+        </p:txBody>
+      </p:sp>
+      <p:pic>
+        <p:nvPicPr>
+          <p:cNvPr id="9" name="Logo" descr="University of Southampton logo">
+            <a:extLst>
+              <a:ext uri="{FF2B5EF4-FFF2-40B4-BE49-F238E27FC236}">
+                <a16:creationId xmlns:a16="http://schemas.microsoft.com/office/drawing/2014/main" id="{BEFAF8AA-C297-DED6-7B1D-52EC0B02C834}"/>
+              </a:ext>
+            </a:extLst>
+          </p:cNvPr>
+          <p:cNvPicPr>
+            <a:picLocks noChangeAspect="1"/>
+          </p:cNvPicPr>
+          <p:nvPr userDrawn="1"/>
+        </p:nvPicPr>
+        <p:blipFill>
+          <a:blip r:embed="rId13"/>
+          <a:stretch>
+            <a:fillRect/>
+          </a:stretch>
+        </p:blipFill>
+        <p:spPr>
+          <a:xfrm>
+            <a:off x="7406640" y="6384033"/>
+            <a:ext cx="1371600" cy="291086"/>
+          </a:xfrm>
+          <a:prstGeom prst="rect">
+            <a:avLst/>
+          </a:prstGeom>
+        </p:spPr>
+      </p:pic>
+      <p:sp>
+        <p:nvSpPr>
+          <p:cNvPr id="10" name="Footer slide number">
+            <a:extLst>
+              <a:ext uri="{FF2B5EF4-FFF2-40B4-BE49-F238E27FC236}">
+                <a16:creationId xmlns:a16="http://schemas.microsoft.com/office/drawing/2014/main" id="{4749B520-07B6-4C48-8DF5-DA1BAEA6020C}"/>
+              </a:ext>
+            </a:extLst>
+          </p:cNvPr>
+          <p:cNvSpPr txBox="1"/>
+          <p:nvPr userDrawn="1"/>
+        </p:nvSpPr>
+        <p:spPr>
+          <a:xfrm>
+            <a:off x="365760" y="6384033"/>
+            <a:ext cx="457200" cy="291086"/>
+          </a:xfrm>
+          <a:prstGeom prst="rect">
+            <a:avLst/>
+          </a:prstGeom>
+          <a:noFill/>
+        </p:spPr>
+        <p:txBody>
+          <a:bodyPr wrap="square" lIns="0" tIns="0" rIns="0" bIns="0" anchor="ctr">
+            <a:noAutofit/>
+          </a:bodyPr>
+          <a:lstStyle/>
+          <a:p>
+            <a:fld id="{B6F15528-21DE-4FAA-801E-634DDDAF4B2B}" type="slidenum">
+              <a:rPr lang="en-GB" sz="1400" dirty="0">
+                <a:solidFill>
+                  <a:srgbClr val="1F497D"/>
+                </a:solidFill>
+              </a:rPr>
+              <a:t>‹#›</a:t>
+            </a:fld>
+            <a:endParaRPr lang="en-GB" sz="1400" dirty="0">
+              <a:solidFill>
+                <a:srgbClr val="1F497D"/>
+              </a:solidFill>
+            </a:endParaRPr>
+          </a:p>
+        </p:txBody>
+      </p:sp>
+      <p:sp>
+        <p:nvSpPr>
+          <p:cNvPr id="11" name="Footer SEAtS">
+            <a:extLst>
+              <a:ext uri="{FF2B5EF4-FFF2-40B4-BE49-F238E27FC236}">
+                <a16:creationId xmlns:a16="http://schemas.microsoft.com/office/drawing/2014/main" id="{8353FC27-3582-24AF-8BED-B709ED52ACF8}"/>
+              </a:ext>
+            </a:extLst>
+          </p:cNvPr>
+          <p:cNvSpPr txBox="1"/>
+          <p:nvPr userDrawn="1"/>
+        </p:nvSpPr>
+        <p:spPr>
+          <a:xfrm>
+            <a:off x="742950" y="6430390"/>
+            <a:ext cx="3200400" cy="291086"/>
+          </a:xfrm>
+          <a:prstGeom prst="rect">
+            <a:avLst/>
+          </a:prstGeom>
+          <a:noFill/>
+        </p:spPr>
+        <p:txBody>
+          <a:bodyPr wrap="square" lIns="0" tIns="0" rIns="0" bIns="0" anchor="ctr">
+            <a:noAutofit/>
+          </a:bodyPr>
+          <a:lstStyle/>
+          <a:p>
+            <a:pPr marL="0" marR="0" indent="0" algn="l" defTabSz="457200" rtl="0" eaLnBrk="1" fontAlgn="auto" latinLnBrk="0" hangingPunct="1">
+              <a:lnSpc>
+                <a:spcPct val="100000"/>
+              </a:lnSpc>
+              <a:spcBef>
+                <a:spcPts val="0"/>
+              </a:spcBef>
+              <a:spcAft>
+                <a:spcPts val="0"/>
+              </a:spcAft>
+              <a:buClrTx/>
+              <a:buSzTx/>
+              <a:buFontTx/>
+              <a:buNone/>
+              <a:tabLst/>
+              <a:defRPr/>
+            </a:pPr>
+            <a:r>
+              <a:rPr lang="en-GB" sz="1000" b="1" dirty="0">
+                <a:solidFill>
+                  <a:srgbClr val="1F497D"/>
+                </a:solidFill>
+              </a:rPr>
+              <a:t>SEAtS | 857647</a:t>
+            </a:r>
+          </a:p>
+          <a:p>
+            <a:r>
+              <a:rPr lang="en-GB" sz="800" b="1" dirty="0">
+                <a:solidFill>
+                  <a:srgbClr val="8C8C8C"/>
+                </a:solidFill>
+              </a:rPr>
+              <a:t>© University of Southampton</a:t>
+            </a:r>
           </a:p>
         </p:txBody>
       </p:sp>
@@ -5379,6 +5743,71 @@
                 <a:schemeClr val="tx2"/>
               </a:solidFill>
             </a:endParaRPr>
+          </a:p>
+        </p:txBody>
+      </p:sp>
+      <p:pic>
+        <p:nvPicPr>
+          <p:cNvPr id="4" name="Picture 3" descr="A qr code with a few squares&#10;&#10;AI-generated content may be incorrect.">
+            <a:extLst>
+              <a:ext uri="{FF2B5EF4-FFF2-40B4-BE49-F238E27FC236}">
+                <a16:creationId xmlns:a16="http://schemas.microsoft.com/office/drawing/2014/main" id="{81979CA4-6024-6E04-CEA0-DA44588E9DC8}"/>
+              </a:ext>
+            </a:extLst>
+          </p:cNvPr>
+          <p:cNvPicPr>
+            <a:picLocks noChangeAspect="1"/>
+          </p:cNvPicPr>
+          <p:nvPr/>
+        </p:nvPicPr>
+        <p:blipFill>
+          <a:blip r:embed="rId2"/>
+          <a:stretch>
+            <a:fillRect/>
+          </a:stretch>
+        </p:blipFill>
+        <p:spPr>
+          <a:xfrm>
+            <a:off x="3640513" y="4024705"/>
+            <a:ext cx="1691336" cy="1696317"/>
+          </a:xfrm>
+          <a:prstGeom prst="rect">
+            <a:avLst/>
+          </a:prstGeom>
+        </p:spPr>
+      </p:pic>
+      <p:sp>
+        <p:nvSpPr>
+          <p:cNvPr id="6" name="TextBox 5">
+            <a:extLst>
+              <a:ext uri="{FF2B5EF4-FFF2-40B4-BE49-F238E27FC236}">
+                <a16:creationId xmlns:a16="http://schemas.microsoft.com/office/drawing/2014/main" id="{B2BB4809-88A2-90A1-53FC-72D3D712E07A}"/>
+              </a:ext>
+            </a:extLst>
+          </p:cNvPr>
+          <p:cNvSpPr txBox="1"/>
+          <p:nvPr/>
+        </p:nvSpPr>
+        <p:spPr>
+          <a:xfrm>
+            <a:off x="3869493" y="5721022"/>
+            <a:ext cx="1233376" cy="461665"/>
+          </a:xfrm>
+          <a:prstGeom prst="rect">
+            <a:avLst/>
+          </a:prstGeom>
+          <a:noFill/>
+        </p:spPr>
+        <p:txBody>
+          <a:bodyPr wrap="square">
+            <a:spAutoFit/>
+          </a:bodyPr>
+          <a:lstStyle/>
+          <a:p>
+            <a:r>
+              <a:rPr lang="en-001" sz="2400" dirty="0"/>
+              <a:t>857647</a:t>
+            </a:r>
           </a:p>
         </p:txBody>
       </p:sp>
@@ -7879,4 +8308,319 @@
     </a:ext>
   </a:extLst>
 </a:theme>
+</file>
+
+<file path=ppt/theme/theme3.xml><?xml version="1.0" encoding="utf-8"?>
+<a:theme xmlns:a="http://schemas.openxmlformats.org/drawingml/2006/main" name="Office Theme">
+  <a:themeElements>
+    <a:clrScheme name="Office">
+      <a:dk1>
+        <a:sysClr val="windowText" lastClr="000000"/>
+      </a:dk1>
+      <a:lt1>
+        <a:sysClr val="window" lastClr="FFFFFF"/>
+      </a:lt1>
+      <a:dk2>
+        <a:srgbClr val="0E2841"/>
+      </a:dk2>
+      <a:lt2>
+        <a:srgbClr val="E8E8E8"/>
+      </a:lt2>
+      <a:accent1>
+        <a:srgbClr val="156082"/>
+      </a:accent1>
+      <a:accent2>
+        <a:srgbClr val="E97132"/>
+      </a:accent2>
+      <a:accent3>
+        <a:srgbClr val="196B24"/>
+      </a:accent3>
+      <a:accent4>
+        <a:srgbClr val="0F9ED5"/>
+      </a:accent4>
+      <a:accent5>
+        <a:srgbClr val="A02B93"/>
+      </a:accent5>
+      <a:accent6>
+        <a:srgbClr val="4EA72E"/>
+      </a:accent6>
+      <a:hlink>
+        <a:srgbClr val="467886"/>
+      </a:hlink>
+      <a:folHlink>
+        <a:srgbClr val="96607D"/>
+      </a:folHlink>
+    </a:clrScheme>
+    <a:fontScheme name="Office">
+      <a:majorFont>
+        <a:latin typeface="Aptos Display" panose="02110004020202020204"/>
+        <a:ea typeface=""/>
+        <a:cs typeface=""/>
+        <a:font script="Jpan" typeface="游ゴシック Light"/>
+        <a:font script="Hang" typeface="맑은 고딕"/>
+        <a:font script="Hans" typeface="等线 Light"/>
+        <a:font script="Hant" typeface="新細明體"/>
+        <a:font script="Arab" typeface="Times New Roman"/>
+        <a:font script="Hebr" typeface="Times New Roman"/>
+        <a:font script="Thai" typeface="Angsana New"/>
+        <a:font script="Ethi" typeface="Nyala"/>
+        <a:font script="Beng" typeface="Vrinda"/>
+        <a:font script="Gujr" typeface="Shruti"/>
+        <a:font script="Khmr" typeface="MoolBoran"/>
+        <a:font script="Knda" typeface="Tunga"/>
+        <a:font script="Guru" typeface="Raavi"/>
+        <a:font script="Cans" typeface="Euphemia"/>
+        <a:font script="Cher" typeface="Plantagenet Cherokee"/>
+        <a:font script="Yiii" typeface="Microsoft Yi Baiti"/>
+        <a:font script="Tibt" typeface="Microsoft Himalaya"/>
+        <a:font script="Thaa" typeface="MV Boli"/>
+        <a:font script="Deva" typeface="Mangal"/>
+        <a:font script="Telu" typeface="Gautami"/>
+        <a:font script="Taml" typeface="Latha"/>
+        <a:font script="Syrc" typeface="Estrangelo Edessa"/>
+        <a:font script="Orya" typeface="Kalinga"/>
+        <a:font script="Mlym" typeface="Kartika"/>
+        <a:font script="Laoo" typeface="DokChampa"/>
+        <a:font script="Sinh" typeface="Iskoola Pota"/>
+        <a:font script="Mong" typeface="Mongolian Baiti"/>
+        <a:font script="Viet" typeface="Times New Roman"/>
+        <a:font script="Uigh" typeface="Microsoft Uighur"/>
+        <a:font script="Geor" typeface="Sylfaen"/>
+        <a:font script="Armn" typeface="Arial"/>
+        <a:font script="Bugi" typeface="Leelawadee UI"/>
+        <a:font script="Bopo" typeface="Microsoft JhengHei"/>
+        <a:font script="Java" typeface="Javanese Text"/>
+        <a:font script="Lisu" typeface="Segoe UI"/>
+        <a:font script="Mymr" typeface="Myanmar Text"/>
+        <a:font script="Nkoo" typeface="Ebrima"/>
+        <a:font script="Olck" typeface="Nirmala UI"/>
+        <a:font script="Osma" typeface="Ebrima"/>
+        <a:font script="Phag" typeface="Phagspa"/>
+        <a:font script="Syrn" typeface="Estrangelo Edessa"/>
+        <a:font script="Syrj" typeface="Estrangelo Edessa"/>
+        <a:font script="Syre" typeface="Estrangelo Edessa"/>
+        <a:font script="Sora" typeface="Nirmala UI"/>
+        <a:font script="Tale" typeface="Microsoft Tai Le"/>
+        <a:font script="Talu" typeface="Microsoft New Tai Lue"/>
+        <a:font script="Tfng" typeface="Ebrima"/>
+      </a:majorFont>
+      <a:minorFont>
+        <a:latin typeface="Aptos" panose="02110004020202020204"/>
+        <a:ea typeface=""/>
+        <a:cs typeface=""/>
+        <a:font script="Jpan" typeface="游ゴシック"/>
+        <a:font script="Hang" typeface="맑은 고딕"/>
+        <a:font script="Hans" typeface="等线"/>
+        <a:font script="Hant" typeface="新細明體"/>
+        <a:font script="Arab" typeface="Arial"/>
+        <a:font script="Hebr" typeface="Arial"/>
+        <a:font script="Thai" typeface="Cordia New"/>
+        <a:font script="Ethi" typeface="Nyala"/>
+        <a:font script="Beng" typeface="Vrinda"/>
+        <a:font script="Gujr" typeface="Shruti"/>
+        <a:font script="Khmr" typeface="DaunPenh"/>
+        <a:font script="Knda" typeface="Tunga"/>
+        <a:font script="Guru" typeface="Raavi"/>
+        <a:font script="Cans" typeface="Euphemia"/>
+        <a:font script="Cher" typeface="Plantagenet Cherokee"/>
+        <a:font script="Yiii" typeface="Microsoft Yi Baiti"/>
+        <a:font script="Tibt" typeface="Microsoft Himalaya"/>
+        <a:font script="Thaa" typeface="MV Boli"/>
+        <a:font script="Deva" typeface="Mangal"/>
+        <a:font script="Telu" typeface="Gautami"/>
+        <a:font script="Taml" typeface="Latha"/>
+        <a:font script="Syrc" typeface="Estrangelo Edessa"/>
+        <a:font script="Orya" typeface="Kalinga"/>
+        <a:font script="Mlym" typeface="Kartika"/>
+        <a:font script="Laoo" typeface="DokChampa"/>
+        <a:font script="Sinh" typeface="Iskoola Pota"/>
+        <a:font script="Mong" typeface="Mongolian Baiti"/>
+        <a:font script="Viet" typeface="Arial"/>
+        <a:font script="Uigh" typeface="Microsoft Uighur"/>
+        <a:font script="Geor" typeface="Sylfaen"/>
+        <a:font script="Armn" typeface="Arial"/>
+        <a:font script="Bugi" typeface="Leelawadee UI"/>
+        <a:font script="Bopo" typeface="Microsoft JhengHei"/>
+        <a:font script="Java" typeface="Javanese Text"/>
+        <a:font script="Lisu" typeface="Segoe UI"/>
+        <a:font script="Mymr" typeface="Myanmar Text"/>
+        <a:font script="Nkoo" typeface="Ebrima"/>
+        <a:font script="Olck" typeface="Nirmala UI"/>
+        <a:font script="Osma" typeface="Ebrima"/>
+        <a:font script="Phag" typeface="Phagspa"/>
+        <a:font script="Syrn" typeface="Estrangelo Edessa"/>
+        <a:font script="Syrj" typeface="Estrangelo Edessa"/>
+        <a:font script="Syre" typeface="Estrangelo Edessa"/>
+        <a:font script="Sora" typeface="Nirmala UI"/>
+        <a:font script="Tale" typeface="Microsoft Tai Le"/>
+        <a:font script="Talu" typeface="Microsoft New Tai Lue"/>
+        <a:font script="Tfng" typeface="Ebrima"/>
+      </a:minorFont>
+    </a:fontScheme>
+    <a:fmtScheme name="Office">
+      <a:fillStyleLst>
+        <a:solidFill>
+          <a:schemeClr val="phClr"/>
+        </a:solidFill>
+        <a:gradFill rotWithShape="1">
+          <a:gsLst>
+            <a:gs pos="0">
+              <a:schemeClr val="phClr">
+                <a:lumMod val="110000"/>
+                <a:satMod val="105000"/>
+                <a:tint val="67000"/>
+              </a:schemeClr>
+            </a:gs>
+            <a:gs pos="50000">
+              <a:schemeClr val="phClr">
+                <a:lumMod val="105000"/>
+                <a:satMod val="103000"/>
+                <a:tint val="73000"/>
+              </a:schemeClr>
+            </a:gs>
+            <a:gs pos="100000">
+              <a:schemeClr val="phClr">
+                <a:lumMod val="105000"/>
+                <a:satMod val="109000"/>
+                <a:tint val="81000"/>
+              </a:schemeClr>
+            </a:gs>
+          </a:gsLst>
+          <a:lin ang="5400000" scaled="0"/>
+        </a:gradFill>
+        <a:gradFill rotWithShape="1">
+          <a:gsLst>
+            <a:gs pos="0">
+              <a:schemeClr val="phClr">
+                <a:satMod val="103000"/>
+                <a:lumMod val="102000"/>
+                <a:tint val="94000"/>
+              </a:schemeClr>
+            </a:gs>
+            <a:gs pos="50000">
+              <a:schemeClr val="phClr">
+                <a:satMod val="110000"/>
+                <a:lumMod val="100000"/>
+                <a:shade val="100000"/>
+              </a:schemeClr>
+            </a:gs>
+            <a:gs pos="100000">
+              <a:schemeClr val="phClr">
+                <a:lumMod val="99000"/>
+                <a:satMod val="120000"/>
+                <a:shade val="78000"/>
+              </a:schemeClr>
+            </a:gs>
+          </a:gsLst>
+          <a:lin ang="5400000" scaled="0"/>
+        </a:gradFill>
+      </a:fillStyleLst>
+      <a:lnStyleLst>
+        <a:ln w="12700" cap="flat" cmpd="sng" algn="ctr">
+          <a:solidFill>
+            <a:schemeClr val="phClr"/>
+          </a:solidFill>
+          <a:prstDash val="solid"/>
+          <a:miter lim="800000"/>
+        </a:ln>
+        <a:ln w="19050" cap="flat" cmpd="sng" algn="ctr">
+          <a:solidFill>
+            <a:schemeClr val="phClr"/>
+          </a:solidFill>
+          <a:prstDash val="solid"/>
+          <a:miter lim="800000"/>
+        </a:ln>
+        <a:ln w="25400" cap="flat" cmpd="sng" algn="ctr">
+          <a:solidFill>
+            <a:schemeClr val="phClr"/>
+          </a:solidFill>
+          <a:prstDash val="solid"/>
+          <a:miter lim="800000"/>
+        </a:ln>
+      </a:lnStyleLst>
+      <a:effectStyleLst>
+        <a:effectStyle>
+          <a:effectLst/>
+        </a:effectStyle>
+        <a:effectStyle>
+          <a:effectLst/>
+        </a:effectStyle>
+        <a:effectStyle>
+          <a:effectLst>
+            <a:outerShdw blurRad="57150" dist="19050" dir="5400000" algn="ctr" rotWithShape="0">
+              <a:srgbClr val="000000">
+                <a:alpha val="63000"/>
+              </a:srgbClr>
+            </a:outerShdw>
+          </a:effectLst>
+        </a:effectStyle>
+      </a:effectStyleLst>
+      <a:bgFillStyleLst>
+        <a:solidFill>
+          <a:schemeClr val="phClr"/>
+        </a:solidFill>
+        <a:solidFill>
+          <a:schemeClr val="phClr">
+            <a:tint val="95000"/>
+            <a:satMod val="170000"/>
+          </a:schemeClr>
+        </a:solidFill>
+        <a:gradFill rotWithShape="1">
+          <a:gsLst>
+            <a:gs pos="0">
+              <a:schemeClr val="phClr">
+                <a:tint val="93000"/>
+                <a:satMod val="150000"/>
+                <a:shade val="98000"/>
+                <a:lumMod val="102000"/>
+              </a:schemeClr>
+            </a:gs>
+            <a:gs pos="50000">
+              <a:schemeClr val="phClr">
+                <a:tint val="98000"/>
+                <a:satMod val="130000"/>
+                <a:shade val="90000"/>
+                <a:lumMod val="103000"/>
+              </a:schemeClr>
+            </a:gs>
+            <a:gs pos="100000">
+              <a:schemeClr val="phClr">
+                <a:shade val="63000"/>
+                <a:satMod val="120000"/>
+              </a:schemeClr>
+            </a:gs>
+          </a:gsLst>
+          <a:lin ang="5400000" scaled="0"/>
+        </a:gradFill>
+      </a:bgFillStyleLst>
+    </a:fmtScheme>
+  </a:themeElements>
+  <a:objectDefaults>
+    <a:lnDef>
+      <a:spPr/>
+      <a:bodyPr/>
+      <a:lstStyle/>
+      <a:style>
+        <a:lnRef idx="2">
+          <a:schemeClr val="accent1"/>
+        </a:lnRef>
+        <a:fillRef idx="0">
+          <a:schemeClr val="accent1"/>
+        </a:fillRef>
+        <a:effectRef idx="1">
+          <a:schemeClr val="accent1"/>
+        </a:effectRef>
+        <a:fontRef idx="minor">
+          <a:schemeClr val="tx1"/>
+        </a:fontRef>
+      </a:style>
+    </a:lnDef>
+  </a:objectDefaults>
+  <a:extraClrSchemeLst/>
+  <a:extLst>
+    <a:ext uri="{05A4C25C-085E-4340-85A3-A5531E510DB2}">
+      <thm15:themeFamily xmlns:thm15="http://schemas.microsoft.com/office/thememl/2012/main" name="Office Theme" id="{2E142A2C-CD16-42D6-873A-C26D2A0506FA}" vid="{1BDDFF52-6CD6-40A5-AB3C-68EB2F1E4D0A}"/>
+    </a:ext>
+  </a:extLst>
+</a:theme>
 </file>
</xml_diff>